<commit_message>
DP1: C1 QA1 complement structure slides (final)
Co-Authored-By: Claude Sonnet 5.5 <noreply@anthropic.com>
Claude-Session: https://claude.ai/code/session_018inK4pZJGzYwjdk7QAyZgn
</commit_message>
<xml_diff>
--- a/doc-mk/DP1/DP1-c1-qa1-complement-structure.pptx
+++ b/doc-mk/DP1/DP1-c1-qa1-complement-structure.pptx
@@ -4735,7 +4735,7 @@
                 <a:latin typeface="맑은 고딕"/>
                 <a:ea typeface="맑은 고딕"/>
               </a:rPr>
-              <a:t>객체당 상태는 last_access_ts + window 횟수뿐(EWMA, 이력, 예측, class prior, type 없음). activity는 새 trigger가 아니라 기존 t</a:t>
+              <a:t>객체당 상태는 last_access_ts + window 횟수뿐(EWMA, 이력, 예측, class prior, type 없음). activity는 새 trigger가 아니라 기존</a:t>
             </a:r>
           </a:p>
           <a:p>
@@ -4752,7 +4752,7 @@
                 <a:latin typeface="맑은 고딕"/>
                 <a:ea typeface="맑은 고딕"/>
               </a:rPr>
-              <a:t>rigger의 후보 축소/가중/정렬에만 쓴다. 새 정책 상수 없음(window=COOLDOWN_S, margin=AFFINITY_MARGIN, share=LINK_S</a:t>
+              <a:t>trigger의 후보 축소/가중/정렬에만 쓴다. 새 정책 상수 없음(window=COOLDOWN_S, margin=AFFINITY_MARGIN,</a:t>
             </a:r>
           </a:p>
           <a:p>
@@ -4769,7 +4769,7 @@
                 <a:latin typeface="맑은 고딕"/>
                 <a:ea typeface="맑은 고딕"/>
               </a:rPr>
-              <a:t>HARE).</a:t>
+              <a:t>share=LINK_SHARE).</a:t>
             </a:r>
           </a:p>
         </p:txBody>
@@ -4846,7 +4846,7 @@
                 <a:latin typeface="맑은 고딕"/>
                 <a:ea typeface="맑은 고딕"/>
               </a:rPr>
-              <a:t>이동 138 대 1,339 GiB (C2), 링크 점유 1.6% 대 10.5%, 결정 연산 3 대 111 ms/run, HBM x0.97 대 x1.21, QA</a:t>
+              <a:t>이동 138 대 1,339 GiB (C2), 링크 점유 1.6% 대 10.5%, 결정 연산 3 대 111 ms/run, HBM x0.97 대 x1.21,</a:t>
             </a:r>
           </a:p>
           <a:p>
@@ -4863,7 +4863,7 @@
                 <a:latin typeface="맑은 고딕"/>
                 <a:ea typeface="맑은 고딕"/>
               </a:rPr>
-              <a:t>4 module 1.75 대 2.50. 보완 후 같은 항목을 재측정해 guard로 쓴다.</a:t>
+              <a:t>QA4 module 1.75 대 2.50. 보완 후 같은 항목을 재측정해 guard로 쓴다.</a:t>
             </a:r>
           </a:p>
         </p:txBody>
@@ -5925,7 +5925,7 @@
                 <a:latin typeface="맑은 고딕"/>
                 <a:ea typeface="맑은 고딕"/>
               </a:rPr>
-              <a:t>신규 side-car: ACCESSED -&gt; last_access_t</a:t>
+              <a:t>신규 side-car: ACCESSED -&gt;</a:t>
             </a:r>
           </a:p>
           <a:p>
@@ -5942,7 +5942,7 @@
                 <a:latin typeface="맑은 고딕"/>
                 <a:ea typeface="맑은 고딕"/>
               </a:rPr>
-              <a:t>s + 8 s window 횟수</a:t>
+              <a:t>last_access_ts + 8 s window 횟수</a:t>
             </a:r>
           </a:p>
         </p:txBody>
@@ -6002,7 +6002,7 @@
                 <a:latin typeface="맑은 고딕"/>
                 <a:ea typeface="맑은 고딕"/>
               </a:rPr>
-              <a:t>D1: 같은 class KV 3쌍(B200)이 QA1 ln 격차의 96.5% (rece</a:t>
+              <a:t>D1: 같은 class KV 3쌍(B200)이 QA1 ln 격차의 96.5%</a:t>
             </a:r>
           </a:p>
           <a:p>
@@ -6019,7 +6019,7 @@
                 <a:latin typeface="맑은 고딕"/>
                 <a:ea typeface="맑은 고딕"/>
               </a:rPr>
-              <a:t>ncy_shift 44.4, idle_kv 33.6, rotating 18.5%). C1 x1.11/1.</a:t>
+              <a:t>(recency_shift 44.4, idle_kv 33.6, rotating 18.5%). C1</a:t>
             </a:r>
           </a:p>
           <a:p>
@@ -6036,7 +6036,7 @@
                 <a:latin typeface="맑은 고딕"/>
                 <a:ea typeface="맑은 고딕"/>
               </a:rPr>
-              <a:t>48/1.19 대 C2 x2.62/2.82/1.70, C1 이동 0.8~1.6회/run </a:t>
+              <a:t>x1.11/1.48/1.19 대 C2 x2.62/2.82/1.70, C1 이동</a:t>
             </a:r>
           </a:p>
           <a:p>
@@ -6053,7 +6053,7 @@
                 <a:latin typeface="맑은 고딕"/>
                 <a:ea typeface="맑은 고딕"/>
               </a:rPr>
-              <a:t>대 C2 21~30회</a:t>
+              <a:t>0.8~1.6회/run 대 C2 21~30회</a:t>
             </a:r>
           </a:p>
         </p:txBody>
@@ -6113,7 +6113,7 @@
                 <a:latin typeface="맑은 고딕"/>
                 <a:ea typeface="맑은 고딕"/>
               </a:rPr>
-              <a:t>QA1 ↑ · QA2 ↑? (TTFT P50) · QA3 ≈ · Q</a:t>
+              <a:t>QA1 ↑ · QA2 ↑? (TTFT P50) · QA3 ≈ ·</a:t>
             </a:r>
           </a:p>
           <a:p>
@@ -6130,7 +6130,7 @@
                 <a:latin typeface="맑은 고딕"/>
                 <a:ea typeface="맑은 고딕"/>
               </a:rPr>
-              <a:t>A4 ≈ (C1 로컬 1 module 예상)</a:t>
+              <a:t>QA4 ≈ (C1 로컬 1 module 예상)</a:t>
             </a:r>
           </a:p>
         </p:txBody>
@@ -6190,7 +6190,7 @@
                 <a:latin typeface="맑은 고딕"/>
                 <a:ea typeface="맑은 고딕"/>
               </a:rPr>
-              <a:t>C2화 drift. fence 필수. 낮은 접근률 noise (hot 2.</a:t>
+              <a:t>C2화 drift. fence 필수. 낮은 접근률 noise (hot</a:t>
             </a:r>
           </a:p>
           <a:p>
@@ -6207,7 +6207,7 @@
                 <a:latin typeface="맑은 고딕"/>
                 <a:ea typeface="맑은 고딕"/>
               </a:rPr>
-              <a:t>8회/window면 0회 확률 약 6%)</a:t>
+              <a:t>2.8회/window면 0회 확률 약 6%)</a:t>
             </a:r>
           </a:p>
         </p:txBody>
@@ -6780,7 +6780,7 @@
                 <a:latin typeface="맑은 고딕"/>
                 <a:ea typeface="맑은 고딕"/>
               </a:rPr>
-              <a:t>victim 정렬: idle 우선 (현재 key = size x res</a:t>
+              <a:t>victim 정렬: idle 우선 (현재 key = size x</a:t>
             </a:r>
           </a:p>
           <a:p>
@@ -6797,7 +6797,7 @@
                 <a:latin typeface="맑은 고딕"/>
                 <a:ea typeface="맑은 고딕"/>
               </a:rPr>
-              <a:t>idency age)</a:t>
+              <a:t>residency age)</a:t>
             </a:r>
           </a:p>
         </p:txBody>
@@ -7242,7 +7242,7 @@
                 <a:latin typeface="맑은 고딕"/>
                 <a:ea typeface="맑은 고딕"/>
               </a:rPr>
-              <a:t>D4: Common 4쌍에서 C1 이동 231~284 GiB, QA1 x0.99~</a:t>
+              <a:t>D4: Common 4쌍에서 C1 이동 231~284 GiB, QA1</a:t>
             </a:r>
           </a:p>
           <a:p>
@@ -7259,7 +7259,7 @@
                 <a:latin typeface="맑은 고딕"/>
                 <a:ea typeface="맑은 고딕"/>
               </a:rPr>
-              <a:t>1.00, TTFT P99 x3.76~4.32 (C1 악화 6쌍, C2 5쌍)</a:t>
+              <a:t>x0.99~1.00, TTFT P99 x3.76~4.32 (C1 악화 6쌍, C2 5쌍)</a:t>
             </a:r>
           </a:p>
         </p:txBody>
@@ -7379,7 +7379,7 @@
                 <a:latin typeface="맑은 고딕"/>
                 <a:ea typeface="맑은 고딕"/>
               </a:rPr>
-              <a:t>host path 경합의 C1 승리(H100 x1.63, B200 x1.</a:t>
+              <a:t>host path 경합의 C1 승리(H100 x1.63, B200</a:t>
             </a:r>
           </a:p>
           <a:p>
@@ -7396,7 +7396,7 @@
                 <a:latin typeface="맑은 고딕"/>
                 <a:ea typeface="맑은 고딕"/>
               </a:rPr>
-              <a:t>37)를 막을 위험. 대역폭 충격을 비용 추정에 반</a:t>
+              <a:t>x1.37)를 막을 위험. 대역폭 충격을 비용 추정에 </a:t>
             </a:r>
           </a:p>
           <a:p>
@@ -7413,7 +7413,7 @@
                 <a:latin typeface="맑은 고딕"/>
                 <a:ea typeface="맑은 고딕"/>
               </a:rPr>
-              <a:t>영해야 함</a:t>
+              <a:t>반영해야 함</a:t>
             </a:r>
           </a:p>
         </p:txBody>
@@ -7644,7 +7644,7 @@
                 <a:latin typeface="맑은 고딕"/>
                 <a:ea typeface="맑은 고딕"/>
               </a:rPr>
-              <a:t>D5: 이동이 burst cap보다 크면 admit 불가. cap 1.0 s에서 </a:t>
+              <a:t>D5: 이동이 burst cap보다 크면 admit 불가. cap 1.0 s에서</a:t>
             </a:r>
           </a:p>
           <a:p>
@@ -7721,7 +7721,7 @@
                 <a:latin typeface="맑은 고딕"/>
                 <a:ea typeface="맑은 고딕"/>
               </a:rPr>
-              <a:t>QA1 ↑? (큰 객체 통과) · QA2 ↑ (꼬리) · </a:t>
+              <a:t>QA1 ↑? (큰 객체 통과) · QA2 ↑ (꼬리) ·</a:t>
             </a:r>
           </a:p>
           <a:p>

</xml_diff>